<commit_message>
docs(recursos): presentación actualizada por el equipo (v5)
Co-Authored-By: Claude Sonnet 5 <noreply@anthropic.com>
</commit_message>
<xml_diff>
--- a/recursos/presentacion_v5.pptx
+++ b/recursos/presentacion_v5.pptx
@@ -2270,6 +2270,13 @@
           </a:solidFill>
           <a:ln/>
         </p:spPr>
+        <p:txBody>
+          <a:bodyPr/>
+          <a:lstStyle/>
+          <a:p>
+            <a:endParaRPr lang="es-CO"/>
+          </a:p>
+        </p:txBody>
       </p:sp>
       <p:sp>
         <p:nvSpPr>
@@ -2473,6 +2480,13 @@
           </a:solidFill>
           <a:ln/>
         </p:spPr>
+        <p:txBody>
+          <a:bodyPr/>
+          <a:lstStyle/>
+          <a:p>
+            <a:endParaRPr lang="es-CO"/>
+          </a:p>
+        </p:txBody>
       </p:sp>
       <p:sp>
         <p:nvSpPr>
@@ -2493,6 +2507,13 @@
           </a:solidFill>
           <a:ln/>
         </p:spPr>
+        <p:txBody>
+          <a:bodyPr/>
+          <a:lstStyle/>
+          <a:p>
+            <a:endParaRPr lang="es-CO"/>
+          </a:p>
+        </p:txBody>
       </p:sp>
       <p:sp>
         <p:nvSpPr>
@@ -2513,6 +2534,13 @@
           </a:solidFill>
           <a:ln/>
         </p:spPr>
+        <p:txBody>
+          <a:bodyPr/>
+          <a:lstStyle/>
+          <a:p>
+            <a:endParaRPr lang="es-CO"/>
+          </a:p>
+        </p:txBody>
       </p:sp>
       <p:sp>
         <p:nvSpPr>
@@ -2715,6 +2743,13 @@
             <a:prstDash val="solid"/>
           </a:ln>
         </p:spPr>
+        <p:txBody>
+          <a:bodyPr/>
+          <a:lstStyle/>
+          <a:p>
+            <a:endParaRPr lang="es-CO"/>
+          </a:p>
+        </p:txBody>
       </p:sp>
       <p:sp>
         <p:nvSpPr>
@@ -3044,6 +3079,13 @@
             </a:outerShdw>
           </a:effectLst>
         </p:spPr>
+        <p:txBody>
+          <a:bodyPr/>
+          <a:lstStyle/>
+          <a:p>
+            <a:endParaRPr lang="es-CO"/>
+          </a:p>
+        </p:txBody>
       </p:sp>
       <p:sp>
         <p:nvSpPr>
@@ -3184,6 +3226,13 @@
             </a:outerShdw>
           </a:effectLst>
         </p:spPr>
+        <p:txBody>
+          <a:bodyPr/>
+          <a:lstStyle/>
+          <a:p>
+            <a:endParaRPr lang="es-CO"/>
+          </a:p>
+        </p:txBody>
       </p:sp>
       <p:sp>
         <p:nvSpPr>
@@ -3324,6 +3373,13 @@
             </a:outerShdw>
           </a:effectLst>
         </p:spPr>
+        <p:txBody>
+          <a:bodyPr/>
+          <a:lstStyle/>
+          <a:p>
+            <a:endParaRPr lang="es-CO"/>
+          </a:p>
+        </p:txBody>
       </p:sp>
       <p:sp>
         <p:nvSpPr>
@@ -3464,6 +3520,13 @@
             </a:outerShdw>
           </a:effectLst>
         </p:spPr>
+        <p:txBody>
+          <a:bodyPr/>
+          <a:lstStyle/>
+          <a:p>
+            <a:endParaRPr lang="es-CO"/>
+          </a:p>
+        </p:txBody>
       </p:sp>
       <p:sp>
         <p:nvSpPr>
@@ -3597,6 +3660,13 @@
           </a:solidFill>
           <a:ln/>
         </p:spPr>
+        <p:txBody>
+          <a:bodyPr/>
+          <a:lstStyle/>
+          <a:p>
+            <a:endParaRPr lang="es-CO"/>
+          </a:p>
+        </p:txBody>
       </p:sp>
       <p:sp>
         <p:nvSpPr>
@@ -3706,7 +3776,7 @@
         </p:nvSpPr>
         <p:spPr>
           <a:xfrm>
-            <a:off x="8275320" y="4832604"/>
+            <a:off x="8275320" y="4841272"/>
             <a:ext cx="365760" cy="228600"/>
           </a:xfrm>
           <a:prstGeom prst="rect">
@@ -3731,7 +3801,7 @@
                 <a:ea typeface="Calibri" pitchFamily="34" charset="-122"/>
                 <a:cs typeface="Calibri" pitchFamily="34" charset="-120"/>
               </a:rPr>
-              <a:t>11</a:t>
+              <a:t>10</a:t>
             </a:r>
             <a:endParaRPr lang="en-US" sz="850" dirty="0"/>
           </a:p>
@@ -3948,6 +4018,13 @@
             </a:outerShdw>
           </a:effectLst>
         </p:spPr>
+        <p:txBody>
+          <a:bodyPr/>
+          <a:lstStyle/>
+          <a:p>
+            <a:endParaRPr lang="es-CO"/>
+          </a:p>
+        </p:txBody>
       </p:sp>
       <p:sp>
         <p:nvSpPr>
@@ -3968,6 +4045,13 @@
           </a:solidFill>
           <a:ln/>
         </p:spPr>
+        <p:txBody>
+          <a:bodyPr/>
+          <a:lstStyle/>
+          <a:p>
+            <a:endParaRPr lang="es-CO"/>
+          </a:p>
+        </p:txBody>
       </p:sp>
       <p:sp>
         <p:nvSpPr>
@@ -4114,6 +4198,13 @@
             </a:outerShdw>
           </a:effectLst>
         </p:spPr>
+        <p:txBody>
+          <a:bodyPr/>
+          <a:lstStyle/>
+          <a:p>
+            <a:endParaRPr lang="es-CO"/>
+          </a:p>
+        </p:txBody>
       </p:sp>
       <p:sp>
         <p:nvSpPr>
@@ -4134,6 +4225,13 @@
           </a:solidFill>
           <a:ln/>
         </p:spPr>
+        <p:txBody>
+          <a:bodyPr/>
+          <a:lstStyle/>
+          <a:p>
+            <a:endParaRPr lang="es-CO"/>
+          </a:p>
+        </p:txBody>
       </p:sp>
       <p:sp>
         <p:nvSpPr>
@@ -4280,6 +4378,13 @@
             </a:outerShdw>
           </a:effectLst>
         </p:spPr>
+        <p:txBody>
+          <a:bodyPr/>
+          <a:lstStyle/>
+          <a:p>
+            <a:endParaRPr lang="es-CO"/>
+          </a:p>
+        </p:txBody>
       </p:sp>
       <p:sp>
         <p:nvSpPr>
@@ -4300,6 +4405,13 @@
           </a:solidFill>
           <a:ln/>
         </p:spPr>
+        <p:txBody>
+          <a:bodyPr/>
+          <a:lstStyle/>
+          <a:p>
+            <a:endParaRPr lang="es-CO"/>
+          </a:p>
+        </p:txBody>
       </p:sp>
       <p:sp>
         <p:nvSpPr>
@@ -4446,6 +4558,13 @@
             </a:outerShdw>
           </a:effectLst>
         </p:spPr>
+        <p:txBody>
+          <a:bodyPr/>
+          <a:lstStyle/>
+          <a:p>
+            <a:endParaRPr lang="es-CO"/>
+          </a:p>
+        </p:txBody>
       </p:sp>
       <p:sp>
         <p:nvSpPr>
@@ -4466,6 +4585,13 @@
           </a:solidFill>
           <a:ln/>
         </p:spPr>
+        <p:txBody>
+          <a:bodyPr/>
+          <a:lstStyle/>
+          <a:p>
+            <a:endParaRPr lang="es-CO"/>
+          </a:p>
+        </p:txBody>
       </p:sp>
       <p:sp>
         <p:nvSpPr>
@@ -4612,6 +4738,13 @@
             </a:outerShdw>
           </a:effectLst>
         </p:spPr>
+        <p:txBody>
+          <a:bodyPr/>
+          <a:lstStyle/>
+          <a:p>
+            <a:endParaRPr lang="es-CO"/>
+          </a:p>
+        </p:txBody>
       </p:sp>
       <p:sp>
         <p:nvSpPr>
@@ -4632,6 +4765,13 @@
           </a:solidFill>
           <a:ln/>
         </p:spPr>
+        <p:txBody>
+          <a:bodyPr/>
+          <a:lstStyle/>
+          <a:p>
+            <a:endParaRPr lang="es-CO"/>
+          </a:p>
+        </p:txBody>
       </p:sp>
       <p:sp>
         <p:nvSpPr>
@@ -4778,6 +4918,13 @@
             </a:outerShdw>
           </a:effectLst>
         </p:spPr>
+        <p:txBody>
+          <a:bodyPr/>
+          <a:lstStyle/>
+          <a:p>
+            <a:endParaRPr lang="es-CO"/>
+          </a:p>
+        </p:txBody>
       </p:sp>
       <p:sp>
         <p:nvSpPr>
@@ -4798,6 +4945,13 @@
           </a:solidFill>
           <a:ln/>
         </p:spPr>
+        <p:txBody>
+          <a:bodyPr/>
+          <a:lstStyle/>
+          <a:p>
+            <a:endParaRPr lang="es-CO"/>
+          </a:p>
+        </p:txBody>
       </p:sp>
       <p:sp>
         <p:nvSpPr>
@@ -5038,7 +5192,7 @@
                 <a:ea typeface="Calibri" pitchFamily="34" charset="-122"/>
                 <a:cs typeface="Calibri" pitchFamily="34" charset="-120"/>
               </a:rPr>
-              <a:t>09</a:t>
+              <a:t>11</a:t>
             </a:r>
             <a:endParaRPr lang="en-US" sz="850" dirty="0"/>
           </a:p>
@@ -5273,6 +5427,13 @@
             </a:outerShdw>
           </a:effectLst>
         </p:spPr>
+        <p:txBody>
+          <a:bodyPr/>
+          <a:lstStyle/>
+          <a:p>
+            <a:endParaRPr lang="es-CO"/>
+          </a:p>
+        </p:txBody>
       </p:sp>
       <p:sp>
         <p:nvSpPr>
@@ -5759,6 +5920,13 @@
             </a:outerShdw>
           </a:effectLst>
         </p:spPr>
+        <p:txBody>
+          <a:bodyPr/>
+          <a:lstStyle/>
+          <a:p>
+            <a:endParaRPr lang="es-CO"/>
+          </a:p>
+        </p:txBody>
       </p:sp>
       <p:sp>
         <p:nvSpPr>
@@ -6167,6 +6335,13 @@
           </a:solidFill>
           <a:ln/>
         </p:spPr>
+        <p:txBody>
+          <a:bodyPr/>
+          <a:lstStyle/>
+          <a:p>
+            <a:endParaRPr lang="es-CO"/>
+          </a:p>
+        </p:txBody>
       </p:sp>
       <p:sp>
         <p:nvSpPr>
@@ -6218,7 +6393,29 @@
                 <a:ea typeface="Calibri" pitchFamily="34" charset="-122"/>
                 <a:cs typeface="Calibri" pitchFamily="34" charset="-120"/>
               </a:rPr>
-              <a:t>cualquiera de los 25.357 datasets del catálogo es consultable — índice semántico completo + acceso por lenguaje natural. 10.280 responden además desde copia local en milisegundos.</a:t>
+              <a:t>cualquiera de </a:t>
+            </a:r>
+            <a:r>
+              <a:rPr lang="en-US" sz="1050" dirty="0" err="1">
+                <a:solidFill>
+                  <a:srgbClr val="D5E4EE"/>
+                </a:solidFill>
+                <a:latin typeface="Calibri" pitchFamily="34" charset="0"/>
+                <a:ea typeface="Calibri" pitchFamily="34" charset="-122"/>
+                <a:cs typeface="Calibri" pitchFamily="34" charset="-120"/>
+              </a:rPr>
+              <a:t>los</a:t>
+            </a:r>
+            <a:r>
+              <a:rPr lang="en-US" sz="1050" dirty="0">
+                <a:solidFill>
+                  <a:srgbClr val="D5E4EE"/>
+                </a:solidFill>
+                <a:latin typeface="Calibri" pitchFamily="34" charset="0"/>
+                <a:ea typeface="Calibri" pitchFamily="34" charset="-122"/>
+                <a:cs typeface="Calibri" pitchFamily="34" charset="-120"/>
+              </a:rPr>
+              <a:t> 25.410 datasets del catálogo es consultable — índice semántico completo + acceso por lenguaje natural. 10.280 responden además desde copia local en milisegundos.</a:t>
             </a:r>
             <a:endParaRPr lang="en-US" sz="1050" dirty="0"/>
           </a:p>
@@ -6319,7 +6516,7 @@
                 <a:ea typeface="Calibri" pitchFamily="34" charset="-122"/>
                 <a:cs typeface="Calibri" pitchFamily="34" charset="-120"/>
               </a:rPr>
-              <a:t>06</a:t>
+              <a:t>12</a:t>
             </a:r>
             <a:endParaRPr lang="en-US" sz="850" dirty="0"/>
           </a:p>
@@ -8896,6 +9093,13 @@
           </a:solidFill>
           <a:ln/>
         </p:spPr>
+        <p:txBody>
+          <a:bodyPr/>
+          <a:lstStyle/>
+          <a:p>
+            <a:endParaRPr lang="es-CO"/>
+          </a:p>
+        </p:txBody>
       </p:sp>
       <p:sp>
         <p:nvSpPr>
@@ -9030,7 +9234,7 @@
                 <a:ea typeface="Calibri" pitchFamily="34" charset="-122"/>
                 <a:cs typeface="Calibri" pitchFamily="34" charset="-120"/>
               </a:rPr>
-              <a:t>21</a:t>
+              <a:t>13</a:t>
             </a:r>
             <a:endParaRPr lang="en-US" sz="850" dirty="0"/>
           </a:p>
@@ -9175,6 +9379,13 @@
             </a:outerShdw>
           </a:effectLst>
         </p:spPr>
+        <p:txBody>
+          <a:bodyPr/>
+          <a:lstStyle/>
+          <a:p>
+            <a:endParaRPr lang="es-CO"/>
+          </a:p>
+        </p:txBody>
       </p:sp>
       <p:sp>
         <p:nvSpPr>
@@ -9543,6 +9754,13 @@
             </a:outerShdw>
           </a:effectLst>
         </p:spPr>
+        <p:txBody>
+          <a:bodyPr/>
+          <a:lstStyle/>
+          <a:p>
+            <a:endParaRPr lang="es-CO"/>
+          </a:p>
+        </p:txBody>
       </p:sp>
       <p:sp>
         <p:nvSpPr>
@@ -9650,6 +9868,13 @@
             </a:outerShdw>
           </a:effectLst>
         </p:spPr>
+        <p:txBody>
+          <a:bodyPr/>
+          <a:lstStyle/>
+          <a:p>
+            <a:endParaRPr lang="es-CO"/>
+          </a:p>
+        </p:txBody>
       </p:sp>
       <p:sp>
         <p:nvSpPr>
@@ -9750,6 +9975,13 @@
           </a:solidFill>
           <a:ln/>
         </p:spPr>
+        <p:txBody>
+          <a:bodyPr/>
+          <a:lstStyle/>
+          <a:p>
+            <a:endParaRPr lang="es-CO"/>
+          </a:p>
+        </p:txBody>
       </p:sp>
       <p:sp>
         <p:nvSpPr>
@@ -9915,17 +10147,9 @@
               <a:buNone/>
             </a:pPr>
             <a:r>
-              <a:rPr lang="en-US" sz="850" dirty="0">
-                <a:solidFill>
-                  <a:srgbClr val="7F8C8D"/>
-                </a:solidFill>
-                <a:latin typeface="Calibri" pitchFamily="34" charset="0"/>
-                <a:ea typeface="Calibri" pitchFamily="34" charset="-122"/>
-                <a:cs typeface="Calibri" pitchFamily="34" charset="-120"/>
-              </a:rPr>
-              <a:t>22</a:t>
-            </a:r>
-            <a:endParaRPr lang="en-US" sz="850" dirty="0"/>
+              <a:rPr lang="en-US" sz="850" dirty="0"/>
+              <a:t>14</a:t>
+            </a:r>
           </a:p>
         </p:txBody>
       </p:sp>
@@ -10068,6 +10292,13 @@
             </a:outerShdw>
           </a:effectLst>
         </p:spPr>
+        <p:txBody>
+          <a:bodyPr/>
+          <a:lstStyle/>
+          <a:p>
+            <a:endParaRPr lang="es-CO"/>
+          </a:p>
+        </p:txBody>
       </p:sp>
       <p:sp>
         <p:nvSpPr>
@@ -10088,6 +10319,13 @@
           </a:solidFill>
           <a:ln/>
         </p:spPr>
+        <p:txBody>
+          <a:bodyPr/>
+          <a:lstStyle/>
+          <a:p>
+            <a:endParaRPr lang="es-CO"/>
+          </a:p>
+        </p:txBody>
       </p:sp>
       <p:sp>
         <p:nvSpPr>
@@ -10195,6 +10433,13 @@
             </a:outerShdw>
           </a:effectLst>
         </p:spPr>
+        <p:txBody>
+          <a:bodyPr/>
+          <a:lstStyle/>
+          <a:p>
+            <a:endParaRPr lang="es-CO"/>
+          </a:p>
+        </p:txBody>
       </p:sp>
       <p:sp>
         <p:nvSpPr>
@@ -10215,6 +10460,13 @@
           </a:solidFill>
           <a:ln/>
         </p:spPr>
+        <p:txBody>
+          <a:bodyPr/>
+          <a:lstStyle/>
+          <a:p>
+            <a:endParaRPr lang="es-CO"/>
+          </a:p>
+        </p:txBody>
       </p:sp>
       <p:sp>
         <p:nvSpPr>
@@ -10322,6 +10574,13 @@
             </a:outerShdw>
           </a:effectLst>
         </p:spPr>
+        <p:txBody>
+          <a:bodyPr/>
+          <a:lstStyle/>
+          <a:p>
+            <a:endParaRPr lang="es-CO"/>
+          </a:p>
+        </p:txBody>
       </p:sp>
       <p:sp>
         <p:nvSpPr>
@@ -10342,6 +10601,13 @@
           </a:solidFill>
           <a:ln/>
         </p:spPr>
+        <p:txBody>
+          <a:bodyPr/>
+          <a:lstStyle/>
+          <a:p>
+            <a:endParaRPr lang="es-CO"/>
+          </a:p>
+        </p:txBody>
       </p:sp>
       <p:sp>
         <p:nvSpPr>
@@ -10449,6 +10715,13 @@
             </a:outerShdw>
           </a:effectLst>
         </p:spPr>
+        <p:txBody>
+          <a:bodyPr/>
+          <a:lstStyle/>
+          <a:p>
+            <a:endParaRPr lang="es-CO"/>
+          </a:p>
+        </p:txBody>
       </p:sp>
       <p:sp>
         <p:nvSpPr>
@@ -10469,6 +10742,13 @@
           </a:solidFill>
           <a:ln/>
         </p:spPr>
+        <p:txBody>
+          <a:bodyPr/>
+          <a:lstStyle/>
+          <a:p>
+            <a:endParaRPr lang="es-CO"/>
+          </a:p>
+        </p:txBody>
       </p:sp>
       <p:sp>
         <p:nvSpPr>
@@ -10662,17 +10942,9 @@
               <a:buNone/>
             </a:pPr>
             <a:r>
-              <a:rPr lang="en-US" sz="850" dirty="0">
-                <a:solidFill>
-                  <a:srgbClr val="7F8C8D"/>
-                </a:solidFill>
-                <a:latin typeface="Calibri" pitchFamily="34" charset="0"/>
-                <a:ea typeface="Calibri" pitchFamily="34" charset="-122"/>
-                <a:cs typeface="Calibri" pitchFamily="34" charset="-120"/>
-              </a:rPr>
-              <a:t>10</a:t>
-            </a:r>
-            <a:endParaRPr lang="en-US" sz="850" dirty="0"/>
+              <a:rPr lang="en-US" sz="850" dirty="0"/>
+              <a:t>15</a:t>
+            </a:r>
           </a:p>
         </p:txBody>
       </p:sp>
@@ -10895,6 +11167,13 @@
           </a:solidFill>
           <a:ln/>
         </p:spPr>
+        <p:txBody>
+          <a:bodyPr/>
+          <a:lstStyle/>
+          <a:p>
+            <a:endParaRPr lang="es-CO"/>
+          </a:p>
+        </p:txBody>
       </p:sp>
       <p:pic>
         <p:nvPicPr>
@@ -11285,6 +11564,13 @@
           </a:solidFill>
           <a:ln/>
         </p:spPr>
+        <p:txBody>
+          <a:bodyPr/>
+          <a:lstStyle/>
+          <a:p>
+            <a:endParaRPr lang="es-CO"/>
+          </a:p>
+        </p:txBody>
       </p:sp>
       <p:pic>
         <p:nvPicPr>
@@ -11432,7 +11718,7 @@
                 <a:ea typeface="Calibri" pitchFamily="34" charset="-122"/>
                 <a:cs typeface="Calibri" pitchFamily="34" charset="-120"/>
               </a:rPr>
-              <a:t>13</a:t>
+              <a:t>16</a:t>
             </a:r>
             <a:endParaRPr lang="en-US" sz="850" dirty="0"/>
           </a:p>
@@ -11729,7 +12015,7 @@
                 <a:ea typeface="Calibri" pitchFamily="34" charset="-122"/>
                 <a:cs typeface="Calibri" pitchFamily="34" charset="-120"/>
               </a:rPr>
-              <a:t>14</a:t>
+              <a:t>17</a:t>
             </a:r>
             <a:endParaRPr lang="en-US" sz="850" dirty="0"/>
           </a:p>
@@ -11946,17 +12232,9 @@
               <a:buNone/>
             </a:pPr>
             <a:r>
-              <a:rPr lang="en-US" sz="850" dirty="0">
-                <a:solidFill>
-                  <a:srgbClr val="7F8C8D"/>
-                </a:solidFill>
-                <a:latin typeface="Calibri" pitchFamily="34" charset="0"/>
-                <a:ea typeface="Calibri" pitchFamily="34" charset="-122"/>
-                <a:cs typeface="Calibri" pitchFamily="34" charset="-120"/>
-              </a:rPr>
-              <a:t>15</a:t>
-            </a:r>
-            <a:endParaRPr lang="en-US" sz="850" dirty="0"/>
+              <a:rPr lang="en-US" sz="850" dirty="0"/>
+              <a:t>18</a:t>
+            </a:r>
           </a:p>
         </p:txBody>
       </p:sp>
@@ -12138,6 +12416,13 @@
             </a:outerShdw>
           </a:effectLst>
         </p:spPr>
+        <p:txBody>
+          <a:bodyPr/>
+          <a:lstStyle/>
+          <a:p>
+            <a:endParaRPr lang="es-CO"/>
+          </a:p>
+        </p:txBody>
       </p:sp>
       <p:pic>
         <p:nvPicPr>
@@ -12269,6 +12554,13 @@
             </a:outerShdw>
           </a:effectLst>
         </p:spPr>
+        <p:txBody>
+          <a:bodyPr/>
+          <a:lstStyle/>
+          <a:p>
+            <a:endParaRPr lang="es-CO"/>
+          </a:p>
+        </p:txBody>
       </p:sp>
       <p:pic>
         <p:nvPicPr>
@@ -12400,6 +12692,13 @@
             </a:outerShdw>
           </a:effectLst>
         </p:spPr>
+        <p:txBody>
+          <a:bodyPr/>
+          <a:lstStyle/>
+          <a:p>
+            <a:endParaRPr lang="es-CO"/>
+          </a:p>
+        </p:txBody>
       </p:sp>
       <p:pic>
         <p:nvPicPr>
@@ -12531,6 +12830,13 @@
             </a:outerShdw>
           </a:effectLst>
         </p:spPr>
+        <p:txBody>
+          <a:bodyPr/>
+          <a:lstStyle/>
+          <a:p>
+            <a:endParaRPr lang="es-CO"/>
+          </a:p>
+        </p:txBody>
       </p:sp>
       <p:pic>
         <p:nvPicPr>
@@ -12717,7 +13023,7 @@
                 <a:ea typeface="Calibri" pitchFamily="34" charset="-122"/>
                 <a:cs typeface="Calibri" pitchFamily="34" charset="-120"/>
               </a:rPr>
-              <a:t>16</a:t>
+              <a:t>19</a:t>
             </a:r>
             <a:endParaRPr lang="en-US" sz="850" dirty="0"/>
           </a:p>
@@ -12784,6 +13090,13 @@
             </a:outerShdw>
           </a:effectLst>
         </p:spPr>
+        <p:txBody>
+          <a:bodyPr/>
+          <a:lstStyle/>
+          <a:p>
+            <a:endParaRPr lang="es-CO"/>
+          </a:p>
+        </p:txBody>
       </p:sp>
       <p:sp>
         <p:nvSpPr>
@@ -12819,6 +13132,13 @@
             </a:outerShdw>
           </a:effectLst>
         </p:spPr>
+        <p:txBody>
+          <a:bodyPr/>
+          <a:lstStyle/>
+          <a:p>
+            <a:endParaRPr lang="es-CO"/>
+          </a:p>
+        </p:txBody>
       </p:sp>
       <p:sp>
         <p:nvSpPr>
@@ -12950,6 +13270,13 @@
             </a:outerShdw>
           </a:effectLst>
         </p:spPr>
+        <p:txBody>
+          <a:bodyPr/>
+          <a:lstStyle/>
+          <a:p>
+            <a:endParaRPr lang="es-CO"/>
+          </a:p>
+        </p:txBody>
       </p:sp>
       <p:pic>
         <p:nvPicPr>
@@ -13081,6 +13408,13 @@
             </a:outerShdw>
           </a:effectLst>
         </p:spPr>
+        <p:txBody>
+          <a:bodyPr/>
+          <a:lstStyle/>
+          <a:p>
+            <a:endParaRPr lang="es-CO"/>
+          </a:p>
+        </p:txBody>
       </p:sp>
       <p:pic>
         <p:nvPicPr>
@@ -13289,6 +13623,13 @@
             </a:outerShdw>
           </a:effectLst>
         </p:spPr>
+        <p:txBody>
+          <a:bodyPr/>
+          <a:lstStyle/>
+          <a:p>
+            <a:endParaRPr lang="es-CO"/>
+          </a:p>
+        </p:txBody>
       </p:sp>
       <p:pic>
         <p:nvPicPr>
@@ -13975,6 +14316,13 @@
             </a:outerShdw>
           </a:effectLst>
         </p:spPr>
+        <p:txBody>
+          <a:bodyPr/>
+          <a:lstStyle/>
+          <a:p>
+            <a:endParaRPr lang="es-CO"/>
+          </a:p>
+        </p:txBody>
       </p:sp>
       <p:pic>
         <p:nvPicPr>
@@ -14106,6 +14454,13 @@
             </a:outerShdw>
           </a:effectLst>
         </p:spPr>
+        <p:txBody>
+          <a:bodyPr/>
+          <a:lstStyle/>
+          <a:p>
+            <a:endParaRPr lang="es-CO"/>
+          </a:p>
+        </p:txBody>
       </p:sp>
       <p:pic>
         <p:nvPicPr>
@@ -14237,6 +14592,13 @@
             </a:outerShdw>
           </a:effectLst>
         </p:spPr>
+        <p:txBody>
+          <a:bodyPr/>
+          <a:lstStyle/>
+          <a:p>
+            <a:endParaRPr lang="es-CO"/>
+          </a:p>
+        </p:txBody>
       </p:sp>
       <p:pic>
         <p:nvPicPr>
@@ -14368,6 +14730,13 @@
             </a:outerShdw>
           </a:effectLst>
         </p:spPr>
+        <p:txBody>
+          <a:bodyPr/>
+          <a:lstStyle/>
+          <a:p>
+            <a:endParaRPr lang="es-CO"/>
+          </a:p>
+        </p:txBody>
       </p:sp>
       <p:pic>
         <p:nvPicPr>
@@ -14499,6 +14868,13 @@
             </a:outerShdw>
           </a:effectLst>
         </p:spPr>
+        <p:txBody>
+          <a:bodyPr/>
+          <a:lstStyle/>
+          <a:p>
+            <a:endParaRPr lang="es-CO"/>
+          </a:p>
+        </p:txBody>
       </p:sp>
       <p:pic>
         <p:nvPicPr>
@@ -14630,6 +15006,13 @@
             </a:outerShdw>
           </a:effectLst>
         </p:spPr>
+        <p:txBody>
+          <a:bodyPr/>
+          <a:lstStyle/>
+          <a:p>
+            <a:endParaRPr lang="es-CO"/>
+          </a:p>
+        </p:txBody>
       </p:sp>
       <p:pic>
         <p:nvPicPr>
@@ -14816,7 +15199,7 @@
                 <a:ea typeface="Calibri" pitchFamily="34" charset="-122"/>
                 <a:cs typeface="Calibri" pitchFamily="34" charset="-120"/>
               </a:rPr>
-              <a:t>17</a:t>
+              <a:t>20</a:t>
             </a:r>
             <a:endParaRPr lang="en-US" sz="850" dirty="0"/>
           </a:p>
@@ -14883,6 +15266,13 @@
             </a:outerShdw>
           </a:effectLst>
         </p:spPr>
+        <p:txBody>
+          <a:bodyPr/>
+          <a:lstStyle/>
+          <a:p>
+            <a:endParaRPr lang="es-CO"/>
+          </a:p>
+        </p:txBody>
       </p:sp>
       <p:sp>
         <p:nvSpPr>
@@ -15029,6 +15419,13 @@
             </a:outerShdw>
           </a:effectLst>
         </p:spPr>
+        <p:txBody>
+          <a:bodyPr/>
+          <a:lstStyle/>
+          <a:p>
+            <a:endParaRPr lang="es-CO"/>
+          </a:p>
+        </p:txBody>
       </p:sp>
       <p:pic>
         <p:nvPicPr>
@@ -15238,6 +15635,13 @@
             </a:outerShdw>
           </a:effectLst>
         </p:spPr>
+        <p:txBody>
+          <a:bodyPr/>
+          <a:lstStyle/>
+          <a:p>
+            <a:endParaRPr lang="es-CO"/>
+          </a:p>
+        </p:txBody>
       </p:sp>
       <p:pic>
         <p:nvPicPr>
@@ -15369,6 +15773,13 @@
             </a:outerShdw>
           </a:effectLst>
         </p:spPr>
+        <p:txBody>
+          <a:bodyPr/>
+          <a:lstStyle/>
+          <a:p>
+            <a:endParaRPr lang="es-CO"/>
+          </a:p>
+        </p:txBody>
       </p:sp>
       <p:pic>
         <p:nvPicPr>
@@ -15555,9 +15966,8 @@
                 <a:ea typeface="Calibri" pitchFamily="34" charset="-122"/>
                 <a:cs typeface="Calibri" pitchFamily="34" charset="-120"/>
               </a:rPr>
-              <a:t>18</a:t>
-            </a:r>
-            <a:endParaRPr lang="en-US" sz="850" dirty="0"/>
+              <a:t>21</a:t>
+            </a:r>
           </a:p>
         </p:txBody>
       </p:sp>
@@ -15799,6 +16209,13 @@
             </a:outerShdw>
           </a:effectLst>
         </p:spPr>
+        <p:txBody>
+          <a:bodyPr/>
+          <a:lstStyle/>
+          <a:p>
+            <a:endParaRPr lang="es-CO"/>
+          </a:p>
+        </p:txBody>
       </p:sp>
       <p:pic>
         <p:nvPicPr>
@@ -15930,6 +16347,13 @@
             </a:outerShdw>
           </a:effectLst>
         </p:spPr>
+        <p:txBody>
+          <a:bodyPr/>
+          <a:lstStyle/>
+          <a:p>
+            <a:endParaRPr lang="es-CO"/>
+          </a:p>
+        </p:txBody>
       </p:sp>
       <p:pic>
         <p:nvPicPr>
@@ -16061,6 +16485,13 @@
             </a:outerShdw>
           </a:effectLst>
         </p:spPr>
+        <p:txBody>
+          <a:bodyPr/>
+          <a:lstStyle/>
+          <a:p>
+            <a:endParaRPr lang="es-CO"/>
+          </a:p>
+        </p:txBody>
       </p:sp>
       <p:pic>
         <p:nvPicPr>
@@ -16192,6 +16623,13 @@
             </a:outerShdw>
           </a:effectLst>
         </p:spPr>
+        <p:txBody>
+          <a:bodyPr/>
+          <a:lstStyle/>
+          <a:p>
+            <a:endParaRPr lang="es-CO"/>
+          </a:p>
+        </p:txBody>
       </p:sp>
       <p:pic>
         <p:nvPicPr>
@@ -16323,6 +16761,13 @@
             </a:outerShdw>
           </a:effectLst>
         </p:spPr>
+        <p:txBody>
+          <a:bodyPr/>
+          <a:lstStyle/>
+          <a:p>
+            <a:endParaRPr lang="es-CO"/>
+          </a:p>
+        </p:txBody>
       </p:sp>
       <p:pic>
         <p:nvPicPr>
@@ -16454,6 +16899,13 @@
             </a:outerShdw>
           </a:effectLst>
         </p:spPr>
+        <p:txBody>
+          <a:bodyPr/>
+          <a:lstStyle/>
+          <a:p>
+            <a:endParaRPr lang="es-CO"/>
+          </a:p>
+        </p:txBody>
       </p:sp>
       <p:pic>
         <p:nvPicPr>
@@ -16640,7 +17092,7 @@
                 <a:ea typeface="Calibri" pitchFamily="34" charset="-122"/>
                 <a:cs typeface="Calibri" pitchFamily="34" charset="-120"/>
               </a:rPr>
-              <a:t>19</a:t>
+              <a:t>22</a:t>
             </a:r>
             <a:endParaRPr lang="en-US" sz="850" dirty="0"/>
           </a:p>
@@ -16698,6 +17150,13 @@
           </a:solidFill>
           <a:ln/>
         </p:spPr>
+        <p:txBody>
+          <a:bodyPr/>
+          <a:lstStyle/>
+          <a:p>
+            <a:endParaRPr lang="es-CO"/>
+          </a:p>
+        </p:txBody>
       </p:sp>
       <p:sp>
         <p:nvSpPr>
@@ -17160,6 +17619,13 @@
             </a:outerShdw>
           </a:effectLst>
         </p:spPr>
+        <p:txBody>
+          <a:bodyPr/>
+          <a:lstStyle/>
+          <a:p>
+            <a:endParaRPr lang="es-CO"/>
+          </a:p>
+        </p:txBody>
       </p:sp>
       <p:sp>
         <p:nvSpPr>
@@ -17182,6 +17648,13 @@
           </a:solidFill>
           <a:ln/>
         </p:spPr>
+        <p:txBody>
+          <a:bodyPr/>
+          <a:lstStyle/>
+          <a:p>
+            <a:endParaRPr lang="es-CO"/>
+          </a:p>
+        </p:txBody>
       </p:sp>
       <p:sp>
         <p:nvSpPr>
@@ -17202,6 +17675,13 @@
           </a:solidFill>
           <a:ln/>
         </p:spPr>
+        <p:txBody>
+          <a:bodyPr/>
+          <a:lstStyle/>
+          <a:p>
+            <a:endParaRPr lang="es-CO"/>
+          </a:p>
+        </p:txBody>
       </p:sp>
       <p:pic>
         <p:nvPicPr>
@@ -17455,6 +17935,13 @@
             </a:outerShdw>
           </a:effectLst>
         </p:spPr>
+        <p:txBody>
+          <a:bodyPr/>
+          <a:lstStyle/>
+          <a:p>
+            <a:endParaRPr lang="es-CO"/>
+          </a:p>
+        </p:txBody>
       </p:sp>
       <p:sp>
         <p:nvSpPr>
@@ -17477,6 +17964,13 @@
           </a:solidFill>
           <a:ln/>
         </p:spPr>
+        <p:txBody>
+          <a:bodyPr/>
+          <a:lstStyle/>
+          <a:p>
+            <a:endParaRPr lang="es-CO"/>
+          </a:p>
+        </p:txBody>
       </p:sp>
       <p:sp>
         <p:nvSpPr>
@@ -17497,6 +17991,13 @@
           </a:solidFill>
           <a:ln/>
         </p:spPr>
+        <p:txBody>
+          <a:bodyPr/>
+          <a:lstStyle/>
+          <a:p>
+            <a:endParaRPr lang="es-CO"/>
+          </a:p>
+        </p:txBody>
       </p:sp>
       <p:pic>
         <p:nvPicPr>
@@ -17838,6 +18339,13 @@
             </a:outerShdw>
           </a:effectLst>
         </p:spPr>
+        <p:txBody>
+          <a:bodyPr/>
+          <a:lstStyle/>
+          <a:p>
+            <a:endParaRPr lang="es-CO"/>
+          </a:p>
+        </p:txBody>
       </p:sp>
       <p:sp>
         <p:nvSpPr>
@@ -17860,6 +18368,13 @@
           </a:solidFill>
           <a:ln/>
         </p:spPr>
+        <p:txBody>
+          <a:bodyPr/>
+          <a:lstStyle/>
+          <a:p>
+            <a:endParaRPr lang="es-CO"/>
+          </a:p>
+        </p:txBody>
       </p:sp>
       <p:sp>
         <p:nvSpPr>
@@ -17880,6 +18395,13 @@
           </a:solidFill>
           <a:ln/>
         </p:spPr>
+        <p:txBody>
+          <a:bodyPr/>
+          <a:lstStyle/>
+          <a:p>
+            <a:endParaRPr lang="es-CO"/>
+          </a:p>
+        </p:txBody>
       </p:sp>
       <p:pic>
         <p:nvPicPr>
@@ -18243,6 +18765,13 @@
             </a:outerShdw>
           </a:effectLst>
         </p:spPr>
+        <p:txBody>
+          <a:bodyPr/>
+          <a:lstStyle/>
+          <a:p>
+            <a:endParaRPr lang="es-CO"/>
+          </a:p>
+        </p:txBody>
       </p:sp>
       <p:sp>
         <p:nvSpPr>
@@ -18265,6 +18794,13 @@
           </a:solidFill>
           <a:ln/>
         </p:spPr>
+        <p:txBody>
+          <a:bodyPr/>
+          <a:lstStyle/>
+          <a:p>
+            <a:endParaRPr lang="es-CO"/>
+          </a:p>
+        </p:txBody>
       </p:sp>
       <p:sp>
         <p:nvSpPr>
@@ -18285,6 +18821,13 @@
           </a:solidFill>
           <a:ln/>
         </p:spPr>
+        <p:txBody>
+          <a:bodyPr/>
+          <a:lstStyle/>
+          <a:p>
+            <a:endParaRPr lang="es-CO"/>
+          </a:p>
+        </p:txBody>
       </p:sp>
       <p:pic>
         <p:nvPicPr>
@@ -18744,6 +19287,13 @@
             </a:outerShdw>
           </a:effectLst>
         </p:spPr>
+        <p:txBody>
+          <a:bodyPr/>
+          <a:lstStyle/>
+          <a:p>
+            <a:endParaRPr lang="es-CO"/>
+          </a:p>
+        </p:txBody>
       </p:sp>
       <p:sp>
         <p:nvSpPr>
@@ -18862,6 +19412,13 @@
             </a:outerShdw>
           </a:effectLst>
         </p:spPr>
+        <p:txBody>
+          <a:bodyPr/>
+          <a:lstStyle/>
+          <a:p>
+            <a:endParaRPr lang="es-CO"/>
+          </a:p>
+        </p:txBody>
       </p:sp>
       <p:sp>
         <p:nvSpPr>
@@ -18882,6 +19439,13 @@
           </a:solidFill>
           <a:ln/>
         </p:spPr>
+        <p:txBody>
+          <a:bodyPr/>
+          <a:lstStyle/>
+          <a:p>
+            <a:endParaRPr lang="es-CO"/>
+          </a:p>
+        </p:txBody>
       </p:sp>
       <p:sp>
         <p:nvSpPr>
@@ -18916,7 +19480,7 @@
                 <a:ea typeface="Trebuchet MS" pitchFamily="34" charset="-122"/>
                 <a:cs typeface="Trebuchet MS" pitchFamily="34" charset="-120"/>
               </a:rPr>
-              <a:t>25.357</a:t>
+              <a:t>25.410</a:t>
             </a:r>
             <a:endParaRPr lang="en-US" sz="2600" dirty="0"/>
           </a:p>
@@ -18989,6 +19553,13 @@
             </a:outerShdw>
           </a:effectLst>
         </p:spPr>
+        <p:txBody>
+          <a:bodyPr/>
+          <a:lstStyle/>
+          <a:p>
+            <a:endParaRPr lang="es-CO"/>
+          </a:p>
+        </p:txBody>
       </p:sp>
       <p:sp>
         <p:nvSpPr>
@@ -19009,6 +19580,13 @@
           </a:solidFill>
           <a:ln/>
         </p:spPr>
+        <p:txBody>
+          <a:bodyPr/>
+          <a:lstStyle/>
+          <a:p>
+            <a:endParaRPr lang="es-CO"/>
+          </a:p>
+        </p:txBody>
       </p:sp>
       <p:sp>
         <p:nvSpPr>
@@ -19116,6 +19694,13 @@
             </a:outerShdw>
           </a:effectLst>
         </p:spPr>
+        <p:txBody>
+          <a:bodyPr/>
+          <a:lstStyle/>
+          <a:p>
+            <a:endParaRPr lang="es-CO"/>
+          </a:p>
+        </p:txBody>
       </p:sp>
       <p:sp>
         <p:nvSpPr>
@@ -19136,6 +19721,13 @@
           </a:solidFill>
           <a:ln/>
         </p:spPr>
+        <p:txBody>
+          <a:bodyPr/>
+          <a:lstStyle/>
+          <a:p>
+            <a:endParaRPr lang="es-CO"/>
+          </a:p>
+        </p:txBody>
       </p:sp>
       <p:sp>
         <p:nvSpPr>
@@ -19243,6 +19835,13 @@
             </a:outerShdw>
           </a:effectLst>
         </p:spPr>
+        <p:txBody>
+          <a:bodyPr/>
+          <a:lstStyle/>
+          <a:p>
+            <a:endParaRPr lang="es-CO"/>
+          </a:p>
+        </p:txBody>
       </p:sp>
       <p:sp>
         <p:nvSpPr>
@@ -19263,6 +19862,13 @@
           </a:solidFill>
           <a:ln/>
         </p:spPr>
+        <p:txBody>
+          <a:bodyPr/>
+          <a:lstStyle/>
+          <a:p>
+            <a:endParaRPr lang="es-CO"/>
+          </a:p>
+        </p:txBody>
       </p:sp>
       <p:sp>
         <p:nvSpPr>
@@ -19399,6 +20005,13 @@
             </a:outerShdw>
           </a:effectLst>
         </p:spPr>
+        <p:txBody>
+          <a:bodyPr/>
+          <a:lstStyle/>
+          <a:p>
+            <a:endParaRPr lang="es-CO"/>
+          </a:p>
+        </p:txBody>
       </p:sp>
       <p:sp>
         <p:nvSpPr>
@@ -19494,7 +20107,7 @@
                 <a:ea typeface="Calibri" pitchFamily="34" charset="-122"/>
                 <a:cs typeface="Calibri" pitchFamily="34" charset="-120"/>
               </a:rPr>
-              <a:t>25.357 hoy</a:t>
+              <a:t>25.410 hoy</a:t>
             </a:r>
             <a:endParaRPr lang="en-US" sz="1250" dirty="0"/>
           </a:p>
@@ -19567,6 +20180,13 @@
             </a:outerShdw>
           </a:effectLst>
         </p:spPr>
+        <p:txBody>
+          <a:bodyPr/>
+          <a:lstStyle/>
+          <a:p>
+            <a:endParaRPr lang="es-CO"/>
+          </a:p>
+        </p:txBody>
       </p:sp>
       <p:sp>
         <p:nvSpPr>
@@ -19835,7 +20455,7 @@
                 <a:ea typeface="Calibri" pitchFamily="34" charset="-122"/>
                 <a:cs typeface="Calibri" pitchFamily="34" charset="-120"/>
               </a:rPr>
-              <a:t>Cifras </a:t>
+              <a:t>Cifras en vivo y </a:t>
             </a:r>
             <a:r>
               <a:rPr lang="en-US" sz="950" i="1" dirty="0" err="1">
@@ -19846,7 +20466,7 @@
                 <a:ea typeface="Calibri" pitchFamily="34" charset="-122"/>
                 <a:cs typeface="Calibri" pitchFamily="34" charset="-120"/>
               </a:rPr>
-              <a:t>en</a:t>
+              <a:t>verificables</a:t>
             </a:r>
             <a:r>
               <a:rPr lang="en-US" sz="950" i="1" dirty="0">
@@ -19857,7 +20477,7 @@
                 <a:ea typeface="Calibri" pitchFamily="34" charset="-122"/>
                 <a:cs typeface="Calibri" pitchFamily="34" charset="-120"/>
               </a:rPr>
-              <a:t> vivo y </a:t>
+              <a:t> · 11.039.185 </a:t>
             </a:r>
             <a:r>
               <a:rPr lang="en-US" sz="950" i="1" dirty="0" err="1">
@@ -19868,7 +20488,84 @@
                 <a:ea typeface="Calibri" pitchFamily="34" charset="-122"/>
                 <a:cs typeface="Calibri" pitchFamily="34" charset="-120"/>
               </a:rPr>
-              <a:t>verificables · 10.991.897 descargas acumuladas · 4.018.725 vistas/mes · corte 23 de julio de 2026</a:t>
+              <a:t>descargas</a:t>
+            </a:r>
+            <a:r>
+              <a:rPr lang="en-US" sz="950" i="1" dirty="0">
+                <a:solidFill>
+                  <a:srgbClr val="7F8C8D"/>
+                </a:solidFill>
+                <a:latin typeface="Calibri" pitchFamily="34" charset="0"/>
+                <a:ea typeface="Calibri" pitchFamily="34" charset="-122"/>
+                <a:cs typeface="Calibri" pitchFamily="34" charset="-120"/>
+              </a:rPr>
+              <a:t> </a:t>
+            </a:r>
+            <a:r>
+              <a:rPr lang="en-US" sz="950" i="1" dirty="0" err="1">
+                <a:solidFill>
+                  <a:srgbClr val="7F8C8D"/>
+                </a:solidFill>
+                <a:latin typeface="Calibri" pitchFamily="34" charset="0"/>
+                <a:ea typeface="Calibri" pitchFamily="34" charset="-122"/>
+                <a:cs typeface="Calibri" pitchFamily="34" charset="-120"/>
+              </a:rPr>
+              <a:t>acumuladas</a:t>
+            </a:r>
+            <a:r>
+              <a:rPr lang="en-US" sz="950" i="1" dirty="0">
+                <a:solidFill>
+                  <a:srgbClr val="7F8C8D"/>
+                </a:solidFill>
+                <a:latin typeface="Calibri" pitchFamily="34" charset="0"/>
+                <a:ea typeface="Calibri" pitchFamily="34" charset="-122"/>
+                <a:cs typeface="Calibri" pitchFamily="34" charset="-120"/>
+              </a:rPr>
+              <a:t> · 3.972.184 vistas/</a:t>
+            </a:r>
+            <a:r>
+              <a:rPr lang="en-US" sz="950" i="1" dirty="0" err="1">
+                <a:solidFill>
+                  <a:srgbClr val="7F8C8D"/>
+                </a:solidFill>
+                <a:latin typeface="Calibri" pitchFamily="34" charset="0"/>
+                <a:ea typeface="Calibri" pitchFamily="34" charset="-122"/>
+                <a:cs typeface="Calibri" pitchFamily="34" charset="-120"/>
+              </a:rPr>
+              <a:t>mes</a:t>
+            </a:r>
+            <a:r>
+              <a:rPr lang="en-US" sz="950" i="1" dirty="0">
+                <a:solidFill>
+                  <a:srgbClr val="7F8C8D"/>
+                </a:solidFill>
+                <a:latin typeface="Calibri" pitchFamily="34" charset="0"/>
+                <a:ea typeface="Calibri" pitchFamily="34" charset="-122"/>
+                <a:cs typeface="Calibri" pitchFamily="34" charset="-120"/>
+              </a:rPr>
+              <a:t> · corte 26 de </a:t>
+            </a:r>
+            <a:r>
+              <a:rPr lang="en-US" sz="950" i="1" dirty="0" err="1">
+                <a:solidFill>
+                  <a:srgbClr val="7F8C8D"/>
+                </a:solidFill>
+                <a:latin typeface="Calibri" pitchFamily="34" charset="0"/>
+                <a:ea typeface="Calibri" pitchFamily="34" charset="-122"/>
+                <a:cs typeface="Calibri" pitchFamily="34" charset="-120"/>
+              </a:rPr>
+              <a:t>julio</a:t>
+            </a:r>
+            <a:r>
+              <a:rPr lang="en-US" sz="950" i="1" dirty="0">
+                <a:solidFill>
+                  <a:srgbClr val="7F8C8D"/>
+                </a:solidFill>
+                <a:latin typeface="Calibri" pitchFamily="34" charset="0"/>
+                <a:ea typeface="Calibri" pitchFamily="34" charset="-122"/>
+                <a:cs typeface="Calibri" pitchFamily="34" charset="-120"/>
+              </a:rPr>
+              <a:t> de 2026</a:t>
             </a:r>
             <a:endParaRPr lang="en-US" sz="950" dirty="0"/>
           </a:p>
@@ -20174,6 +20871,13 @@
             </a:outerShdw>
           </a:effectLst>
         </p:spPr>
+        <p:txBody>
+          <a:bodyPr/>
+          <a:lstStyle/>
+          <a:p>
+            <a:endParaRPr lang="es-CO"/>
+          </a:p>
+        </p:txBody>
       </p:sp>
       <p:pic>
         <p:nvPicPr>
@@ -20305,6 +21009,13 @@
             </a:outerShdw>
           </a:effectLst>
         </p:spPr>
+        <p:txBody>
+          <a:bodyPr/>
+          <a:lstStyle/>
+          <a:p>
+            <a:endParaRPr lang="es-CO"/>
+          </a:p>
+        </p:txBody>
       </p:sp>
       <p:pic>
         <p:nvPicPr>
@@ -20436,6 +21147,13 @@
             </a:outerShdw>
           </a:effectLst>
         </p:spPr>
+        <p:txBody>
+          <a:bodyPr/>
+          <a:lstStyle/>
+          <a:p>
+            <a:endParaRPr lang="es-CO"/>
+          </a:p>
+        </p:txBody>
       </p:sp>
       <p:pic>
         <p:nvPicPr>
@@ -20655,6 +21373,13 @@
             </a:outerShdw>
           </a:effectLst>
         </p:spPr>
+        <p:txBody>
+          <a:bodyPr/>
+          <a:lstStyle/>
+          <a:p>
+            <a:endParaRPr lang="es-CO"/>
+          </a:p>
+        </p:txBody>
       </p:sp>
       <p:pic>
         <p:nvPicPr>
@@ -21156,6 +21881,13 @@
           </a:solidFill>
           <a:ln/>
         </p:spPr>
+        <p:txBody>
+          <a:bodyPr/>
+          <a:lstStyle/>
+          <a:p>
+            <a:endParaRPr lang="es-CO"/>
+          </a:p>
+        </p:txBody>
       </p:sp>
       <p:sp>
         <p:nvSpPr>
@@ -21176,6 +21908,13 @@
           </a:solidFill>
           <a:ln/>
         </p:spPr>
+        <p:txBody>
+          <a:bodyPr/>
+          <a:lstStyle/>
+          <a:p>
+            <a:endParaRPr lang="es-CO"/>
+          </a:p>
+        </p:txBody>
       </p:sp>
       <p:sp>
         <p:nvSpPr>
@@ -21315,6 +22054,13 @@
           </a:solidFill>
           <a:ln/>
         </p:spPr>
+        <p:txBody>
+          <a:bodyPr/>
+          <a:lstStyle/>
+          <a:p>
+            <a:endParaRPr lang="es-CO"/>
+          </a:p>
+        </p:txBody>
       </p:sp>
       <p:sp>
         <p:nvSpPr>
@@ -21335,6 +22081,13 @@
           </a:solidFill>
           <a:ln/>
         </p:spPr>
+        <p:txBody>
+          <a:bodyPr/>
+          <a:lstStyle/>
+          <a:p>
+            <a:endParaRPr lang="es-CO"/>
+          </a:p>
+        </p:txBody>
       </p:sp>
       <p:sp>
         <p:nvSpPr>
@@ -21474,6 +22227,13 @@
           </a:solidFill>
           <a:ln/>
         </p:spPr>
+        <p:txBody>
+          <a:bodyPr/>
+          <a:lstStyle/>
+          <a:p>
+            <a:endParaRPr lang="es-CO"/>
+          </a:p>
+        </p:txBody>
       </p:sp>
       <p:sp>
         <p:nvSpPr>
@@ -21494,6 +22254,13 @@
           </a:solidFill>
           <a:ln/>
         </p:spPr>
+        <p:txBody>
+          <a:bodyPr/>
+          <a:lstStyle/>
+          <a:p>
+            <a:endParaRPr lang="es-CO"/>
+          </a:p>
+        </p:txBody>
       </p:sp>
       <p:sp>
         <p:nvSpPr>
@@ -21633,6 +22400,13 @@
           </a:solidFill>
           <a:ln/>
         </p:spPr>
+        <p:txBody>
+          <a:bodyPr/>
+          <a:lstStyle/>
+          <a:p>
+            <a:endParaRPr lang="es-CO"/>
+          </a:p>
+        </p:txBody>
       </p:sp>
       <p:sp>
         <p:nvSpPr>
@@ -21653,6 +22427,13 @@
           </a:solidFill>
           <a:ln/>
         </p:spPr>
+        <p:txBody>
+          <a:bodyPr/>
+          <a:lstStyle/>
+          <a:p>
+            <a:endParaRPr lang="es-CO"/>
+          </a:p>
+        </p:txBody>
       </p:sp>
       <p:sp>
         <p:nvSpPr>
@@ -21792,6 +22573,13 @@
           </a:solidFill>
           <a:ln/>
         </p:spPr>
+        <p:txBody>
+          <a:bodyPr/>
+          <a:lstStyle/>
+          <a:p>
+            <a:endParaRPr lang="es-CO"/>
+          </a:p>
+        </p:txBody>
       </p:sp>
       <p:sp>
         <p:nvSpPr>
@@ -21812,6 +22600,13 @@
           </a:solidFill>
           <a:ln/>
         </p:spPr>
+        <p:txBody>
+          <a:bodyPr/>
+          <a:lstStyle/>
+          <a:p>
+            <a:endParaRPr lang="es-CO"/>
+          </a:p>
+        </p:txBody>
       </p:sp>
       <p:sp>
         <p:nvSpPr>
@@ -21951,6 +22746,13 @@
           </a:solidFill>
           <a:ln/>
         </p:spPr>
+        <p:txBody>
+          <a:bodyPr/>
+          <a:lstStyle/>
+          <a:p>
+            <a:endParaRPr lang="es-CO"/>
+          </a:p>
+        </p:txBody>
       </p:sp>
       <p:sp>
         <p:nvSpPr>
@@ -21971,6 +22773,13 @@
           </a:solidFill>
           <a:ln/>
         </p:spPr>
+        <p:txBody>
+          <a:bodyPr/>
+          <a:lstStyle/>
+          <a:p>
+            <a:endParaRPr lang="es-CO"/>
+          </a:p>
+        </p:txBody>
       </p:sp>
       <p:sp>
         <p:nvSpPr>
@@ -22625,6 +23434,13 @@
           </a:solidFill>
           <a:ln/>
         </p:spPr>
+        <p:txBody>
+          <a:bodyPr/>
+          <a:lstStyle/>
+          <a:p>
+            <a:endParaRPr lang="es-CO"/>
+          </a:p>
+        </p:txBody>
       </p:sp>
       <p:sp>
         <p:nvSpPr>
@@ -22645,6 +23461,13 @@
           </a:solidFill>
           <a:ln/>
         </p:spPr>
+        <p:txBody>
+          <a:bodyPr/>
+          <a:lstStyle/>
+          <a:p>
+            <a:endParaRPr lang="es-CO"/>
+          </a:p>
+        </p:txBody>
       </p:sp>
       <p:sp>
         <p:nvSpPr>
@@ -22955,6 +23778,13 @@
           </a:solidFill>
           <a:ln/>
         </p:spPr>
+        <p:txBody>
+          <a:bodyPr/>
+          <a:lstStyle/>
+          <a:p>
+            <a:endParaRPr lang="es-CO"/>
+          </a:p>
+        </p:txBody>
       </p:sp>
       <p:sp>
         <p:nvSpPr>
@@ -22975,6 +23805,13 @@
           </a:solidFill>
           <a:ln/>
         </p:spPr>
+        <p:txBody>
+          <a:bodyPr/>
+          <a:lstStyle/>
+          <a:p>
+            <a:endParaRPr lang="es-CO"/>
+          </a:p>
+        </p:txBody>
       </p:sp>
       <p:sp>
         <p:nvSpPr>
@@ -23285,6 +24122,13 @@
           </a:solidFill>
           <a:ln/>
         </p:spPr>
+        <p:txBody>
+          <a:bodyPr/>
+          <a:lstStyle/>
+          <a:p>
+            <a:endParaRPr lang="es-CO"/>
+          </a:p>
+        </p:txBody>
       </p:sp>
       <p:sp>
         <p:nvSpPr>
@@ -23305,6 +24149,13 @@
           </a:solidFill>
           <a:ln/>
         </p:spPr>
+        <p:txBody>
+          <a:bodyPr/>
+          <a:lstStyle/>
+          <a:p>
+            <a:endParaRPr lang="es-CO"/>
+          </a:p>
+        </p:txBody>
       </p:sp>
       <p:sp>
         <p:nvSpPr>
@@ -23615,6 +24466,13 @@
           </a:solidFill>
           <a:ln/>
         </p:spPr>
+        <p:txBody>
+          <a:bodyPr/>
+          <a:lstStyle/>
+          <a:p>
+            <a:endParaRPr lang="es-CO"/>
+          </a:p>
+        </p:txBody>
       </p:sp>
       <p:sp>
         <p:nvSpPr>
@@ -23635,6 +24493,13 @@
           </a:solidFill>
           <a:ln/>
         </p:spPr>
+        <p:txBody>
+          <a:bodyPr/>
+          <a:lstStyle/>
+          <a:p>
+            <a:endParaRPr lang="es-CO"/>
+          </a:p>
+        </p:txBody>
       </p:sp>
       <p:sp>
         <p:nvSpPr>
@@ -24145,6 +25010,13 @@
           </a:solidFill>
           <a:ln/>
         </p:spPr>
+        <p:txBody>
+          <a:bodyPr/>
+          <a:lstStyle/>
+          <a:p>
+            <a:endParaRPr lang="es-CO"/>
+          </a:p>
+        </p:txBody>
       </p:sp>
       <p:sp>
         <p:nvSpPr>
@@ -24213,6 +25085,13 @@
             </a:outerShdw>
           </a:effectLst>
         </p:spPr>
+        <p:txBody>
+          <a:bodyPr/>
+          <a:lstStyle/>
+          <a:p>
+            <a:endParaRPr lang="es-CO"/>
+          </a:p>
+        </p:txBody>
       </p:sp>
       <p:sp>
         <p:nvSpPr>
@@ -24596,6 +25475,13 @@
             </a:outerShdw>
           </a:effectLst>
         </p:spPr>
+        <p:txBody>
+          <a:bodyPr/>
+          <a:lstStyle/>
+          <a:p>
+            <a:endParaRPr lang="es-CO"/>
+          </a:p>
+        </p:txBody>
       </p:sp>
       <p:sp>
         <p:nvSpPr>
@@ -24979,6 +25865,13 @@
             </a:outerShdw>
           </a:effectLst>
         </p:spPr>
+        <p:txBody>
+          <a:bodyPr/>
+          <a:lstStyle/>
+          <a:p>
+            <a:endParaRPr lang="es-CO"/>
+          </a:p>
+        </p:txBody>
       </p:sp>
       <p:sp>
         <p:nvSpPr>
@@ -25417,7 +26310,7 @@
                 <a:ea typeface="Calibri" pitchFamily="34" charset="-122"/>
                 <a:cs typeface="Calibri" pitchFamily="34" charset="-120"/>
               </a:rPr>
-              <a:t>08</a:t>
+              <a:t>09</a:t>
             </a:r>
             <a:endParaRPr lang="en-US" sz="850" dirty="0"/>
           </a:p>

</xml_diff>